<commit_message>
Add call, SMS, and WhatsApp screening feature; implement platform channels for Android integration and Flutter UI updates.
</commit_message>
<xml_diff>
--- a/docs/pitch_deck/ChengetAI-Pitch-Deck.pptx
+++ b/docs/pitch_deck/ChengetAI-Pitch-Deck.pptx
@@ -1945,7 +1945,7 @@
       </p:grpSpPr>
       <p:pic>
         <p:nvPicPr>
-          <p:cNvPr id="2" name="Image 0" descr="/home/user/ChengetAi/docs/assets/logo-mark.png">    </p:cNvPr>
+          <p:cNvPr id="2" name="Image 0" descr="/Users/Lester/Documents/GitHub/ChengetAi/docs/assets/logo-mark.png">    </p:cNvPr>
           <p:cNvPicPr>
             <a:picLocks noChangeAspect="1"/>
           </p:cNvPicPr>
@@ -2541,7 +2541,7 @@
                 <a:ea typeface="Arial" pitchFamily="34" charset="-122"/>
                 <a:cs typeface="Arial" pitchFamily="34" charset="-120"/>
               </a:rPr>
-              <a:t>73</a:t>
+              <a:t>94</a:t>
             </a:r>
             <a:endParaRPr lang="en-US" sz="4400" dirty="0"/>
           </a:p>
@@ -5856,7 +5856,7 @@
         <p:spPr>
           <a:xfrm>
             <a:off x="566928" y="5120640"/>
-            <a:ext cx="5120640" cy="274320"/>
+            <a:ext cx="5669280" cy="274320"/>
           </a:xfrm>
           <a:prstGeom prst="rect">
             <a:avLst/>
@@ -5880,7 +5880,7 @@
                 <a:ea typeface="Calibri" pitchFamily="34" charset="-122"/>
                 <a:cs typeface="Calibri" pitchFamily="34" charset="-120"/>
               </a:rPr>
-              <a:t>Product, backend and AI engineering, architecture, compliance</a:t>
+              <a:t>Sole developer — product, backend and AI engineering, architecture, Flutter + web UI, compliance</a:t>
             </a:r>
             <a:endParaRPr lang="en-US" sz="1200" dirty="0"/>
           </a:p>
@@ -5889,45 +5889,6 @@
       <p:sp>
         <p:nvSpPr>
           <p:cNvPr id="23" name="Text 21"/>
-          <p:cNvSpPr txBox="1"/>
-          <p:nvPr/>
-        </p:nvSpPr>
-        <p:spPr>
-          <a:xfrm>
-            <a:off x="566928" y="5413248"/>
-            <a:ext cx="5669280" cy="274320"/>
-          </a:xfrm>
-          <a:prstGeom prst="rect">
-            <a:avLst/>
-          </a:prstGeom>
-          <a:noFill/>
-          <a:ln/>
-        </p:spPr>
-        <p:txBody>
-          <a:bodyPr wrap="square" lIns="0" tIns="0" rIns="0" bIns="0" rtlCol="0" anchor="ctr"/>
-          <a:lstStyle/>
-          <a:p>
-            <a:pPr indent="0" marL="0">
-              <a:buNone/>
-            </a:pPr>
-            <a:r>
-              <a:rPr lang="en-US" sz="1150" i="1" dirty="0">
-                <a:solidFill>
-                  <a:srgbClr val="8FB5AC"/>
-                </a:solidFill>
-                <a:latin typeface="Calibri" pitchFamily="34" charset="0"/>
-                <a:ea typeface="Calibri" pitchFamily="34" charset="-122"/>
-                <a:cs typeface="Calibri" pitchFamily="34" charset="-120"/>
-              </a:rPr>
-              <a:t>Frontend contribution: Agnes Goora (Flutter and web UI)</a:t>
-            </a:r>
-            <a:endParaRPr lang="en-US" sz="1150" dirty="0"/>
-          </a:p>
-        </p:txBody>
-      </p:sp>
-      <p:sp>
-        <p:nvSpPr>
-          <p:cNvPr id="24" name="Text 22"/>
           <p:cNvSpPr txBox="1"/>
           <p:nvPr/>
         </p:nvSpPr>
@@ -5966,7 +5927,7 @@
       </p:sp>
       <p:sp>
         <p:nvSpPr>
-          <p:cNvPr id="25" name="Text 23"/>
+          <p:cNvPr id="24" name="Text 22"/>
           <p:cNvSpPr txBox="1"/>
           <p:nvPr/>
         </p:nvSpPr>
@@ -9222,7 +9183,7 @@
       </p:sp>
       <p:pic>
         <p:nvPicPr>
-          <p:cNvPr id="4" name="Image 0" descr="/home/user/ChengetAi/docs/screenshots/admin-overview.png">    </p:cNvPr>
+          <p:cNvPr id="4" name="Image 0" descr="/Users/Lester/Documents/GitHub/ChengetAi/docs/screenshots/admin-overview.png">    </p:cNvPr>
           <p:cNvPicPr>
             <a:picLocks noChangeAspect="1"/>
           </p:cNvPicPr>

</xml_diff>